<commit_message>
fix(reads): Anthropic 81K cover spacing + value font auto-fit
- Cover: subtitle box 0.32 -> 0.55in to allow 2-line wrap
- Cover: source line y 2.05 -> 2.25; stat cards top 3.6 -> 3.55, h 2.6 -> 2.85
- Cover: stat value box widen + 2-line allowed (e.g. 'Open-ended survey')
- Tiered _fit_size: short values stay 36pt, long values shrink to 24/16/14pt
- Context stat_band: auto-shrink value + label gets horizontal padding
</commit_message>
<xml_diff>
--- a/public/decks/anthropic-81k-economics.pptx
+++ b/public/decks/anthropic-81k-economics.pptx
@@ -3264,7 +3264,7 @@
         <p:spPr>
           <a:xfrm>
             <a:off x="457200" y="1444752"/>
-            <a:ext cx="11247120" cy="292608"/>
+            <a:ext cx="11247120" cy="502920"/>
           </a:xfrm>
           <a:prstGeom prst="rect">
             <a:avLst/>
@@ -3277,7 +3277,11 @@
           </a:bodyPr>
           <a:lstStyle/>
           <a:p>
-            <a:pPr algn="l"/>
+            <a:pPr algn="l">
+              <a:lnSpc>
+                <a:spcPct val="120000"/>
+              </a:lnSpc>
+            </a:pPr>
             <a:r>
               <a:rPr sz="1150" b="0" i="1">
                 <a:solidFill>
@@ -3403,7 +3407,7 @@
         </p:nvSpPr>
         <p:spPr>
           <a:xfrm>
-            <a:off x="457200" y="1874519"/>
+            <a:off x="457200" y="2057400"/>
             <a:ext cx="10972800" cy="256032"/>
           </a:xfrm>
           <a:prstGeom prst="rect">
@@ -3438,8 +3442,8 @@
         </p:nvSpPr>
         <p:spPr>
           <a:xfrm>
-            <a:off x="457200" y="3291840"/>
-            <a:ext cx="2695879" cy="2377440"/>
+            <a:off x="457200" y="3246120"/>
+            <a:ext cx="2695879" cy="2606040"/>
           </a:xfrm>
           <a:prstGeom prst="rect">
             <a:avLst/>
@@ -3483,7 +3487,7 @@
         </p:nvSpPr>
         <p:spPr>
           <a:xfrm>
-            <a:off x="457200" y="3291840"/>
+            <a:off x="457200" y="3246120"/>
             <a:ext cx="2695879" cy="36576"/>
           </a:xfrm>
           <a:prstGeom prst="rect">
@@ -3528,8 +3532,8 @@
         </p:nvSpPr>
         <p:spPr>
           <a:xfrm>
-            <a:off x="457200" y="3611880"/>
-            <a:ext cx="2695879" cy="868680"/>
+            <a:off x="548640" y="3566160"/>
+            <a:ext cx="2512999" cy="1051560"/>
           </a:xfrm>
           <a:prstGeom prst="rect">
             <a:avLst/>
@@ -3542,7 +3546,11 @@
           </a:bodyPr>
           <a:lstStyle/>
           <a:p>
-            <a:pPr algn="ctr"/>
+            <a:pPr algn="ctr">
+              <a:lnSpc>
+                <a:spcPct val="110000"/>
+              </a:lnSpc>
+            </a:pPr>
             <a:r>
               <a:rPr sz="3600" b="1" i="0">
                 <a:solidFill>
@@ -3563,7 +3571,7 @@
         </p:nvSpPr>
         <p:spPr>
           <a:xfrm>
-            <a:off x="1530819" y="4709160"/>
+            <a:off x="1530819" y="4800600"/>
             <a:ext cx="548640" cy="22860"/>
           </a:xfrm>
           <a:prstGeom prst="rect">
@@ -3608,8 +3616,8 @@
         </p:nvSpPr>
         <p:spPr>
           <a:xfrm>
-            <a:off x="594360" y="4892040"/>
-            <a:ext cx="2421559" cy="685800"/>
+            <a:off x="594360" y="4937760"/>
+            <a:ext cx="2421559" cy="822960"/>
           </a:xfrm>
           <a:prstGeom prst="rect">
             <a:avLst/>
@@ -3622,7 +3630,11 @@
           </a:bodyPr>
           <a:lstStyle/>
           <a:p>
-            <a:pPr algn="ctr"/>
+            <a:pPr algn="ctr">
+              <a:lnSpc>
+                <a:spcPct val="120000"/>
+              </a:lnSpc>
+            </a:pPr>
             <a:r>
               <a:rPr sz="1100" b="0" i="1">
                 <a:solidFill>
@@ -3643,8 +3655,8 @@
         </p:nvSpPr>
         <p:spPr>
           <a:xfrm>
-            <a:off x="3317671" y="3291840"/>
-            <a:ext cx="2695879" cy="2377440"/>
+            <a:off x="3317671" y="3246120"/>
+            <a:ext cx="2695879" cy="2606040"/>
           </a:xfrm>
           <a:prstGeom prst="rect">
             <a:avLst/>
@@ -3688,7 +3700,7 @@
         </p:nvSpPr>
         <p:spPr>
           <a:xfrm>
-            <a:off x="3317671" y="3291840"/>
+            <a:off x="3317671" y="3246120"/>
             <a:ext cx="2695879" cy="36576"/>
           </a:xfrm>
           <a:prstGeom prst="rect">
@@ -3733,8 +3745,8 @@
         </p:nvSpPr>
         <p:spPr>
           <a:xfrm>
-            <a:off x="3317671" y="3611880"/>
-            <a:ext cx="2695879" cy="868680"/>
+            <a:off x="3409111" y="3566160"/>
+            <a:ext cx="2512999" cy="1051560"/>
           </a:xfrm>
           <a:prstGeom prst="rect">
             <a:avLst/>
@@ -3747,7 +3759,11 @@
           </a:bodyPr>
           <a:lstStyle/>
           <a:p>
-            <a:pPr algn="ctr"/>
+            <a:pPr algn="ctr">
+              <a:lnSpc>
+                <a:spcPct val="110000"/>
+              </a:lnSpc>
+            </a:pPr>
             <a:r>
               <a:rPr sz="3600" b="1" i="0">
                 <a:solidFill>
@@ -3768,7 +3784,7 @@
         </p:nvSpPr>
         <p:spPr>
           <a:xfrm>
-            <a:off x="4391291" y="4709160"/>
+            <a:off x="4391291" y="4800600"/>
             <a:ext cx="548640" cy="22860"/>
           </a:xfrm>
           <a:prstGeom prst="rect">
@@ -3813,8 +3829,8 @@
         </p:nvSpPr>
         <p:spPr>
           <a:xfrm>
-            <a:off x="3454831" y="4892040"/>
-            <a:ext cx="2421559" cy="685800"/>
+            <a:off x="3454831" y="4937760"/>
+            <a:ext cx="2421559" cy="822960"/>
           </a:xfrm>
           <a:prstGeom prst="rect">
             <a:avLst/>
@@ -3827,7 +3843,11 @@
           </a:bodyPr>
           <a:lstStyle/>
           <a:p>
-            <a:pPr algn="ctr"/>
+            <a:pPr algn="ctr">
+              <a:lnSpc>
+                <a:spcPct val="120000"/>
+              </a:lnSpc>
+            </a:pPr>
             <a:r>
               <a:rPr sz="1100" b="0" i="1">
                 <a:solidFill>
@@ -3848,8 +3868,8 @@
         </p:nvSpPr>
         <p:spPr>
           <a:xfrm>
-            <a:off x="6178143" y="3291840"/>
-            <a:ext cx="2695879" cy="2377440"/>
+            <a:off x="6178143" y="3246120"/>
+            <a:ext cx="2695879" cy="2606040"/>
           </a:xfrm>
           <a:prstGeom prst="rect">
             <a:avLst/>
@@ -3893,7 +3913,7 @@
         </p:nvSpPr>
         <p:spPr>
           <a:xfrm>
-            <a:off x="6178143" y="3291840"/>
+            <a:off x="6178143" y="3246120"/>
             <a:ext cx="2695879" cy="36576"/>
           </a:xfrm>
           <a:prstGeom prst="rect">
@@ -3938,8 +3958,8 @@
         </p:nvSpPr>
         <p:spPr>
           <a:xfrm>
-            <a:off x="6178143" y="3611880"/>
-            <a:ext cx="2695879" cy="868680"/>
+            <a:off x="6269583" y="3566160"/>
+            <a:ext cx="2512999" cy="1051560"/>
           </a:xfrm>
           <a:prstGeom prst="rect">
             <a:avLst/>
@@ -3952,7 +3972,11 @@
           </a:bodyPr>
           <a:lstStyle/>
           <a:p>
-            <a:pPr algn="ctr"/>
+            <a:pPr algn="ctr">
+              <a:lnSpc>
+                <a:spcPct val="110000"/>
+              </a:lnSpc>
+            </a:pPr>
             <a:r>
               <a:rPr sz="3600" b="1" i="0">
                 <a:solidFill>
@@ -3973,7 +3997,7 @@
         </p:nvSpPr>
         <p:spPr>
           <a:xfrm>
-            <a:off x="7251763" y="4709160"/>
+            <a:off x="7251763" y="4800600"/>
             <a:ext cx="548640" cy="22860"/>
           </a:xfrm>
           <a:prstGeom prst="rect">
@@ -4018,8 +4042,8 @@
         </p:nvSpPr>
         <p:spPr>
           <a:xfrm>
-            <a:off x="6315303" y="4892040"/>
-            <a:ext cx="2421559" cy="685800"/>
+            <a:off x="6315303" y="4937760"/>
+            <a:ext cx="2421559" cy="822960"/>
           </a:xfrm>
           <a:prstGeom prst="rect">
             <a:avLst/>
@@ -4032,7 +4056,11 @@
           </a:bodyPr>
           <a:lstStyle/>
           <a:p>
-            <a:pPr algn="ctr"/>
+            <a:pPr algn="ctr">
+              <a:lnSpc>
+                <a:spcPct val="120000"/>
+              </a:lnSpc>
+            </a:pPr>
             <a:r>
               <a:rPr sz="1100" b="0" i="1">
                 <a:solidFill>
@@ -4053,8 +4081,8 @@
         </p:nvSpPr>
         <p:spPr>
           <a:xfrm>
-            <a:off x="9038615" y="3291840"/>
-            <a:ext cx="2695879" cy="2377440"/>
+            <a:off x="9038615" y="3246120"/>
+            <a:ext cx="2695879" cy="2606040"/>
           </a:xfrm>
           <a:prstGeom prst="rect">
             <a:avLst/>
@@ -4098,7 +4126,7 @@
         </p:nvSpPr>
         <p:spPr>
           <a:xfrm>
-            <a:off x="9038615" y="3291840"/>
+            <a:off x="9038615" y="3246120"/>
             <a:ext cx="2695879" cy="36576"/>
           </a:xfrm>
           <a:prstGeom prst="rect">
@@ -4143,8 +4171,8 @@
         </p:nvSpPr>
         <p:spPr>
           <a:xfrm>
-            <a:off x="9038615" y="3611880"/>
-            <a:ext cx="2695879" cy="868680"/>
+            <a:off x="9130055" y="3566160"/>
+            <a:ext cx="2512999" cy="1051560"/>
           </a:xfrm>
           <a:prstGeom prst="rect">
             <a:avLst/>
@@ -4157,9 +4185,13 @@
           </a:bodyPr>
           <a:lstStyle/>
           <a:p>
-            <a:pPr algn="ctr"/>
-            <a:r>
-              <a:rPr sz="2000" b="1" i="0">
+            <a:pPr algn="ctr">
+              <a:lnSpc>
+                <a:spcPct val="110000"/>
+              </a:lnSpc>
+            </a:pPr>
+            <a:r>
+              <a:rPr sz="1600" b="1" i="0">
                 <a:solidFill>
                   <a:srgbClr val="460073"/>
                 </a:solidFill>
@@ -4178,7 +4210,7 @@
         </p:nvSpPr>
         <p:spPr>
           <a:xfrm>
-            <a:off x="10112235" y="4709160"/>
+            <a:off x="10112235" y="4800600"/>
             <a:ext cx="548640" cy="22860"/>
           </a:xfrm>
           <a:prstGeom prst="rect">
@@ -4223,8 +4255,8 @@
         </p:nvSpPr>
         <p:spPr>
           <a:xfrm>
-            <a:off x="9175775" y="4892040"/>
-            <a:ext cx="2421559" cy="685800"/>
+            <a:off x="9175775" y="4937760"/>
+            <a:ext cx="2421559" cy="822960"/>
           </a:xfrm>
           <a:prstGeom prst="rect">
             <a:avLst/>
@@ -4237,7 +4269,11 @@
           </a:bodyPr>
           <a:lstStyle/>
           <a:p>
-            <a:pPr algn="ctr"/>
+            <a:pPr algn="ctr">
+              <a:lnSpc>
+                <a:spcPct val="120000"/>
+              </a:lnSpc>
+            </a:pPr>
             <a:r>
               <a:rPr sz="1100" b="0" i="1">
                 <a:solidFill>
@@ -4427,7 +4463,7 @@
         <p:spPr>
           <a:xfrm>
             <a:off x="457200" y="1444752"/>
-            <a:ext cx="11247120" cy="292608"/>
+            <a:ext cx="11247120" cy="502920"/>
           </a:xfrm>
           <a:prstGeom prst="rect">
             <a:avLst/>
@@ -4440,7 +4476,11 @@
           </a:bodyPr>
           <a:lstStyle/>
           <a:p>
-            <a:pPr algn="l"/>
+            <a:pPr algn="l">
+              <a:lnSpc>
+                <a:spcPct val="120000"/>
+              </a:lnSpc>
+            </a:pPr>
             <a:r>
               <a:rPr sz="1150" b="0" i="1">
                 <a:solidFill>
@@ -5599,7 +5639,7 @@
         <p:spPr>
           <a:xfrm>
             <a:off x="457200" y="1444752"/>
-            <a:ext cx="11247120" cy="292608"/>
+            <a:ext cx="11247120" cy="502920"/>
           </a:xfrm>
           <a:prstGeom prst="rect">
             <a:avLst/>
@@ -5612,7 +5652,11 @@
           </a:bodyPr>
           <a:lstStyle/>
           <a:p>
-            <a:pPr algn="l"/>
+            <a:pPr algn="l">
+              <a:lnSpc>
+                <a:spcPct val="120000"/>
+              </a:lnSpc>
+            </a:pPr>
             <a:r>
               <a:rPr sz="1150" b="0" i="1">
                 <a:solidFill>
@@ -7475,7 +7519,7 @@
         <p:spPr>
           <a:xfrm>
             <a:off x="457200" y="1444752"/>
-            <a:ext cx="11247120" cy="292608"/>
+            <a:ext cx="11247120" cy="502920"/>
           </a:xfrm>
           <a:prstGeom prst="rect">
             <a:avLst/>
@@ -7488,7 +7532,11 @@
           </a:bodyPr>
           <a:lstStyle/>
           <a:p>
-            <a:pPr algn="l"/>
+            <a:pPr algn="l">
+              <a:lnSpc>
+                <a:spcPct val="120000"/>
+              </a:lnSpc>
+            </a:pPr>
             <a:r>
               <a:rPr sz="1150" b="0" i="1">
                 <a:solidFill>
@@ -9422,7 +9470,7 @@
         <p:spPr>
           <a:xfrm>
             <a:off x="457200" y="1444752"/>
-            <a:ext cx="11247120" cy="292608"/>
+            <a:ext cx="11247120" cy="502920"/>
           </a:xfrm>
           <a:prstGeom prst="rect">
             <a:avLst/>
@@ -9435,7 +9483,11 @@
           </a:bodyPr>
           <a:lstStyle/>
           <a:p>
-            <a:pPr algn="l"/>
+            <a:pPr algn="l">
+              <a:lnSpc>
+                <a:spcPct val="120000"/>
+              </a:lnSpc>
+            </a:pPr>
             <a:r>
               <a:rPr sz="1150" b="0" i="1">
                 <a:solidFill>
@@ -10900,7 +10952,7 @@
         <p:spPr>
           <a:xfrm>
             <a:off x="457200" y="1444752"/>
-            <a:ext cx="11247120" cy="292608"/>
+            <a:ext cx="11247120" cy="502920"/>
           </a:xfrm>
           <a:prstGeom prst="rect">
             <a:avLst/>
@@ -10913,7 +10965,11 @@
           </a:bodyPr>
           <a:lstStyle/>
           <a:p>
-            <a:pPr algn="l"/>
+            <a:pPr algn="l">
+              <a:lnSpc>
+                <a:spcPct val="120000"/>
+              </a:lnSpc>
+            </a:pPr>
             <a:r>
               <a:rPr sz="1150" b="0" i="1">
                 <a:solidFill>
@@ -12069,7 +12125,7 @@
         <p:spPr>
           <a:xfrm>
             <a:off x="457200" y="1444752"/>
-            <a:ext cx="11247120" cy="292608"/>
+            <a:ext cx="11247120" cy="502920"/>
           </a:xfrm>
           <a:prstGeom prst="rect">
             <a:avLst/>
@@ -12082,7 +12138,11 @@
           </a:bodyPr>
           <a:lstStyle/>
           <a:p>
-            <a:pPr algn="l"/>
+            <a:pPr algn="l">
+              <a:lnSpc>
+                <a:spcPct val="120000"/>
+              </a:lnSpc>
+            </a:pPr>
             <a:r>
               <a:rPr sz="1150" b="0" i="1">
                 <a:solidFill>
@@ -13292,7 +13352,7 @@
         <p:spPr>
           <a:xfrm>
             <a:off x="457200" y="1444752"/>
-            <a:ext cx="11247120" cy="292608"/>
+            <a:ext cx="11247120" cy="502920"/>
           </a:xfrm>
           <a:prstGeom prst="rect">
             <a:avLst/>
@@ -13305,7 +13365,11 @@
           </a:bodyPr>
           <a:lstStyle/>
           <a:p>
-            <a:pPr algn="l"/>
+            <a:pPr algn="l">
+              <a:lnSpc>
+                <a:spcPct val="120000"/>
+              </a:lnSpc>
+            </a:pPr>
             <a:r>
               <a:rPr sz="1150" b="0" i="1">
                 <a:solidFill>
@@ -13840,7 +13904,7 @@
         <p:spPr>
           <a:xfrm>
             <a:off x="457200" y="1444752"/>
-            <a:ext cx="11247120" cy="292608"/>
+            <a:ext cx="11247120" cy="502920"/>
           </a:xfrm>
           <a:prstGeom prst="rect">
             <a:avLst/>
@@ -13853,7 +13917,11 @@
           </a:bodyPr>
           <a:lstStyle/>
           <a:p>
-            <a:pPr algn="l"/>
+            <a:pPr algn="l">
+              <a:lnSpc>
+                <a:spcPct val="120000"/>
+              </a:lnSpc>
+            </a:pPr>
             <a:r>
               <a:rPr sz="1150" b="0" i="1">
                 <a:solidFill>
@@ -14694,7 +14762,7 @@
         </p:nvSpPr>
         <p:spPr>
           <a:xfrm>
-            <a:off x="457200" y="6089904"/>
+            <a:off x="457200" y="6071616"/>
             <a:ext cx="3759098" cy="365760"/>
           </a:xfrm>
           <a:prstGeom prst="rect">
@@ -14729,8 +14797,8 @@
         </p:nvSpPr>
         <p:spPr>
           <a:xfrm>
-            <a:off x="457200" y="6473952"/>
-            <a:ext cx="3759098" cy="292608"/>
+            <a:off x="548640" y="6455664"/>
+            <a:ext cx="3576218" cy="310896"/>
           </a:xfrm>
           <a:prstGeom prst="rect">
             <a:avLst/>
@@ -14745,7 +14813,7 @@
           <a:p>
             <a:pPr algn="ctr"/>
             <a:r>
-              <a:rPr sz="950" b="0" i="1">
+              <a:rPr sz="900" b="0" i="1">
                 <a:solidFill>
                   <a:srgbClr val="4A4A5E"/>
                 </a:solidFill>
@@ -14809,7 +14877,7 @@
         </p:nvSpPr>
         <p:spPr>
           <a:xfrm>
-            <a:off x="4216298" y="6089904"/>
+            <a:off x="4216298" y="6071616"/>
             <a:ext cx="3759098" cy="365760"/>
           </a:xfrm>
           <a:prstGeom prst="rect">
@@ -14844,8 +14912,8 @@
         </p:nvSpPr>
         <p:spPr>
           <a:xfrm>
-            <a:off x="4216298" y="6473952"/>
-            <a:ext cx="3759098" cy="292608"/>
+            <a:off x="4307738" y="6455664"/>
+            <a:ext cx="3576218" cy="310896"/>
           </a:xfrm>
           <a:prstGeom prst="rect">
             <a:avLst/>
@@ -14860,7 +14928,7 @@
           <a:p>
             <a:pPr algn="ctr"/>
             <a:r>
-              <a:rPr sz="950" b="0" i="1">
+              <a:rPr sz="900" b="0" i="1">
                 <a:solidFill>
                   <a:srgbClr val="4A4A5E"/>
                 </a:solidFill>
@@ -14924,7 +14992,7 @@
         </p:nvSpPr>
         <p:spPr>
           <a:xfrm>
-            <a:off x="7975396" y="6089904"/>
+            <a:off x="7975396" y="6071616"/>
             <a:ext cx="3759098" cy="365760"/>
           </a:xfrm>
           <a:prstGeom prst="rect">
@@ -14959,8 +15027,8 @@
         </p:nvSpPr>
         <p:spPr>
           <a:xfrm>
-            <a:off x="7975396" y="6473952"/>
-            <a:ext cx="3759098" cy="292608"/>
+            <a:off x="8066836" y="6455664"/>
+            <a:ext cx="3576218" cy="310896"/>
           </a:xfrm>
           <a:prstGeom prst="rect">
             <a:avLst/>
@@ -14975,7 +15043,7 @@
           <a:p>
             <a:pPr algn="ctr"/>
             <a:r>
-              <a:rPr sz="950" b="0" i="1">
+              <a:rPr sz="900" b="0" i="1">
                 <a:solidFill>
                   <a:srgbClr val="4A4A5E"/>
                 </a:solidFill>
@@ -15163,7 +15231,7 @@
         <p:spPr>
           <a:xfrm>
             <a:off x="457200" y="1444752"/>
-            <a:ext cx="11247120" cy="292608"/>
+            <a:ext cx="11247120" cy="502920"/>
           </a:xfrm>
           <a:prstGeom prst="rect">
             <a:avLst/>
@@ -15176,7 +15244,11 @@
           </a:bodyPr>
           <a:lstStyle/>
           <a:p>
-            <a:pPr algn="l"/>
+            <a:pPr algn="l">
+              <a:lnSpc>
+                <a:spcPct val="120000"/>
+              </a:lnSpc>
+            </a:pPr>
             <a:r>
               <a:rPr sz="1150" b="0" i="1">
                 <a:solidFill>
@@ -17395,7 +17467,7 @@
         <p:spPr>
           <a:xfrm>
             <a:off x="457200" y="1444752"/>
-            <a:ext cx="11247120" cy="292608"/>
+            <a:ext cx="11247120" cy="502920"/>
           </a:xfrm>
           <a:prstGeom prst="rect">
             <a:avLst/>
@@ -17408,7 +17480,11 @@
           </a:bodyPr>
           <a:lstStyle/>
           <a:p>
-            <a:pPr algn="l"/>
+            <a:pPr algn="l">
+              <a:lnSpc>
+                <a:spcPct val="120000"/>
+              </a:lnSpc>
+            </a:pPr>
             <a:r>
               <a:rPr sz="1150" b="0" i="1">
                 <a:solidFill>
@@ -19668,7 +19744,7 @@
         <p:spPr>
           <a:xfrm>
             <a:off x="457200" y="1444752"/>
-            <a:ext cx="11247120" cy="292608"/>
+            <a:ext cx="11247120" cy="502920"/>
           </a:xfrm>
           <a:prstGeom prst="rect">
             <a:avLst/>
@@ -19681,7 +19757,11 @@
           </a:bodyPr>
           <a:lstStyle/>
           <a:p>
-            <a:pPr algn="l"/>
+            <a:pPr algn="l">
+              <a:lnSpc>
+                <a:spcPct val="120000"/>
+              </a:lnSpc>
+            </a:pPr>
             <a:r>
               <a:rPr sz="1150" b="0" i="1">
                 <a:solidFill>
@@ -20515,7 +20595,7 @@
         <p:spPr>
           <a:xfrm>
             <a:off x="457200" y="1444752"/>
-            <a:ext cx="11247120" cy="292608"/>
+            <a:ext cx="11247120" cy="502920"/>
           </a:xfrm>
           <a:prstGeom prst="rect">
             <a:avLst/>
@@ -20528,7 +20608,11 @@
           </a:bodyPr>
           <a:lstStyle/>
           <a:p>
-            <a:pPr algn="l"/>
+            <a:pPr algn="l">
+              <a:lnSpc>
+                <a:spcPct val="120000"/>
+              </a:lnSpc>
+            </a:pPr>
             <a:r>
               <a:rPr sz="1150" b="0" i="1">
                 <a:solidFill>

</xml_diff>

<commit_message>
fix(reads-ppt): aggressive stat_grid value auto-shrink, prevent rewrap
stat_grid col_w content area is ~2.67" wide. The previous _fit_size
fell back to 44pt for 7-8 char values like 'Dec 2025' or '48% / 40%',
which still wrapped to 2 lines and clipped into the label row below.

Switch stat_grid to a hard-coded length→size table:
  \u22645 chars \u2192 48pt | 6 \u2192 42 | 7 \u2192 36 | 8 \u2192 30 | 9 \u2192 26 | \u226510 \u2192 22

Regenerates both decks:
- Karpathy Sequoia 2026 (col 2 'Dec 2025')
- Anthropic 81K Economics (col 4 '48% / 40%') - same latent bug
</commit_message>
<xml_diff>
--- a/public/decks/anthropic-81k-economics.pptx
+++ b/public/decks/anthropic-81k-economics.pptx
@@ -11044,7 +11044,7 @@
               </a:lnSpc>
             </a:pPr>
             <a:r>
-              <a:rPr sz="4800" b="1" i="0">
+              <a:rPr sz="3600" b="1" i="0">
                 <a:solidFill>
                   <a:srgbClr val="141413"/>
                 </a:solidFill>
@@ -11206,7 +11206,7 @@
               </a:lnSpc>
             </a:pPr>
             <a:r>
-              <a:rPr sz="4800" b="1" i="0">
+              <a:rPr sz="4200" b="1" i="0">
                 <a:solidFill>
                   <a:srgbClr val="141413"/>
                 </a:solidFill>
@@ -11530,7 +11530,7 @@
               </a:lnSpc>
             </a:pPr>
             <a:r>
-              <a:rPr sz="4400" b="1" i="0">
+              <a:rPr sz="2600" b="1" i="0">
                 <a:solidFill>
                   <a:srgbClr val="141413"/>
                 </a:solidFill>

</xml_diff>

<commit_message>
fix(reads-ppt): action_list rows overflowing into next row
Karpathy P13 (and Stanford P13) action_list rows had row_h=0.6" with
11pt `what` body — long phrases (~150 chars) wrapped to 3 lines and
the third line bled into the next row's container, producing visual
overlap across all 5 rows.

Two combined fixes:
1. layout: lift top to 3.65" and extend bottom to 7.00" -> row_h
   grows from 0.60" to 0.67" (12% more vertical breathing room).
2. parallel-element body sizing: add _ACTION_BODY_TABLE and
   _ACTION_VALUE_TABLE so `what` and `value` auto-shrink from
   11pt → 9pt (or 8pt) when the longest entry in the group exceeds
   capacity. All 5 rows share the same sizes — uniform hierarchy
   preserved.

Karpathy/Stanford now render at 9pt what / 8pt value; 81K stays at
10pt what / 9pt value (shorter content). Pixel-verified all rows in
Karpathy P13 now stay within their containers.
</commit_message>
<xml_diff>
--- a/public/decks/anthropic-81k-economics.pptx
+++ b/public/decks/anthropic-81k-economics.pptx
@@ -6470,8 +6470,8 @@
         </p:nvSpPr>
         <p:spPr>
           <a:xfrm>
-            <a:off x="640080" y="3520440"/>
-            <a:ext cx="777240" cy="548640"/>
+            <a:off x="640080" y="3337560"/>
+            <a:ext cx="777240" cy="612648"/>
           </a:xfrm>
           <a:prstGeom prst="rect">
             <a:avLst/>
@@ -6505,8 +6505,8 @@
         </p:nvSpPr>
         <p:spPr>
           <a:xfrm>
-            <a:off x="1417320" y="3611880"/>
-            <a:ext cx="19050" cy="365760"/>
+            <a:off x="1417320" y="3429000"/>
+            <a:ext cx="19050" cy="429768"/>
           </a:xfrm>
           <a:prstGeom prst="rect">
             <a:avLst/>
@@ -6550,8 +6550,8 @@
         </p:nvSpPr>
         <p:spPr>
           <a:xfrm>
-            <a:off x="1691640" y="3520440"/>
-            <a:ext cx="3200400" cy="548640"/>
+            <a:off x="1691640" y="3337560"/>
+            <a:ext cx="3200400" cy="612648"/>
           </a:xfrm>
           <a:prstGeom prst="rect">
             <a:avLst/>
@@ -6589,8 +6589,8 @@
         </p:nvSpPr>
         <p:spPr>
           <a:xfrm>
-            <a:off x="5074920" y="3520440"/>
-            <a:ext cx="3931920" cy="548640"/>
+            <a:off x="5074920" y="3337560"/>
+            <a:ext cx="3931920" cy="612648"/>
           </a:xfrm>
           <a:prstGeom prst="rect">
             <a:avLst/>
@@ -6605,11 +6605,11 @@
           <a:p>
             <a:pPr algn="l">
               <a:lnSpc>
-                <a:spcPct val="132000"/>
+                <a:spcPct val="128000"/>
               </a:lnSpc>
             </a:pPr>
             <a:r>
-              <a:rPr sz="1100" b="0" i="0">
+              <a:rPr sz="1000" b="0" i="0">
                 <a:solidFill>
                   <a:srgbClr val="141413"/>
                 </a:solidFill>
@@ -6628,8 +6628,8 @@
         </p:nvSpPr>
         <p:spPr>
           <a:xfrm>
-            <a:off x="9189720" y="3520440"/>
-            <a:ext cx="2286000" cy="548640"/>
+            <a:off x="9189720" y="3337560"/>
+            <a:ext cx="2286000" cy="612648"/>
           </a:xfrm>
           <a:prstGeom prst="rect">
             <a:avLst/>
@@ -6644,11 +6644,11 @@
           <a:p>
             <a:pPr algn="l">
               <a:lnSpc>
-                <a:spcPct val="130000"/>
+                <a:spcPct val="128000"/>
               </a:lnSpc>
             </a:pPr>
             <a:r>
-              <a:rPr sz="1000" b="0" i="1">
+              <a:rPr sz="900" b="0" i="1">
                 <a:solidFill>
                   <a:srgbClr val="D97757"/>
                 </a:solidFill>
@@ -6667,7 +6667,7 @@
         </p:nvSpPr>
         <p:spPr>
           <a:xfrm>
-            <a:off x="640080" y="4061460"/>
+            <a:off x="640080" y="3942588"/>
             <a:ext cx="10911535" cy="6350"/>
           </a:xfrm>
           <a:prstGeom prst="rect">
@@ -6712,8 +6712,8 @@
         </p:nvSpPr>
         <p:spPr>
           <a:xfrm>
-            <a:off x="640080" y="4069080"/>
-            <a:ext cx="777240" cy="548640"/>
+            <a:off x="640080" y="3950208"/>
+            <a:ext cx="777240" cy="612648"/>
           </a:xfrm>
           <a:prstGeom prst="rect">
             <a:avLst/>
@@ -6747,8 +6747,8 @@
         </p:nvSpPr>
         <p:spPr>
           <a:xfrm>
-            <a:off x="1417320" y="4160520"/>
-            <a:ext cx="19050" cy="365760"/>
+            <a:off x="1417320" y="4041648"/>
+            <a:ext cx="19050" cy="429768"/>
           </a:xfrm>
           <a:prstGeom prst="rect">
             <a:avLst/>
@@ -6792,8 +6792,8 @@
         </p:nvSpPr>
         <p:spPr>
           <a:xfrm>
-            <a:off x="1691640" y="4069080"/>
-            <a:ext cx="3200400" cy="548640"/>
+            <a:off x="1691640" y="3950208"/>
+            <a:ext cx="3200400" cy="612648"/>
           </a:xfrm>
           <a:prstGeom prst="rect">
             <a:avLst/>
@@ -6831,8 +6831,8 @@
         </p:nvSpPr>
         <p:spPr>
           <a:xfrm>
-            <a:off x="5074920" y="4069080"/>
-            <a:ext cx="3931920" cy="548640"/>
+            <a:off x="5074920" y="3950208"/>
+            <a:ext cx="3931920" cy="612648"/>
           </a:xfrm>
           <a:prstGeom prst="rect">
             <a:avLst/>
@@ -6847,11 +6847,11 @@
           <a:p>
             <a:pPr algn="l">
               <a:lnSpc>
-                <a:spcPct val="132000"/>
+                <a:spcPct val="128000"/>
               </a:lnSpc>
             </a:pPr>
             <a:r>
-              <a:rPr sz="1100" b="0" i="0">
+              <a:rPr sz="1000" b="0" i="0">
                 <a:solidFill>
                   <a:srgbClr val="141413"/>
                 </a:solidFill>
@@ -6870,8 +6870,8 @@
         </p:nvSpPr>
         <p:spPr>
           <a:xfrm>
-            <a:off x="9189720" y="4069080"/>
-            <a:ext cx="2286000" cy="548640"/>
+            <a:off x="9189720" y="3950208"/>
+            <a:ext cx="2286000" cy="612648"/>
           </a:xfrm>
           <a:prstGeom prst="rect">
             <a:avLst/>
@@ -6886,11 +6886,11 @@
           <a:p>
             <a:pPr algn="l">
               <a:lnSpc>
-                <a:spcPct val="130000"/>
+                <a:spcPct val="128000"/>
               </a:lnSpc>
             </a:pPr>
             <a:r>
-              <a:rPr sz="1000" b="0" i="1">
+              <a:rPr sz="900" b="0" i="1">
                 <a:solidFill>
                   <a:srgbClr val="6A9BCC"/>
                 </a:solidFill>
@@ -6909,7 +6909,7 @@
         </p:nvSpPr>
         <p:spPr>
           <a:xfrm>
-            <a:off x="640080" y="4610100"/>
+            <a:off x="640080" y="4555236"/>
             <a:ext cx="10911535" cy="6350"/>
           </a:xfrm>
           <a:prstGeom prst="rect">
@@ -6954,8 +6954,8 @@
         </p:nvSpPr>
         <p:spPr>
           <a:xfrm>
-            <a:off x="640080" y="4617720"/>
-            <a:ext cx="777240" cy="548640"/>
+            <a:off x="640080" y="4562856"/>
+            <a:ext cx="777240" cy="612648"/>
           </a:xfrm>
           <a:prstGeom prst="rect">
             <a:avLst/>
@@ -6989,8 +6989,8 @@
         </p:nvSpPr>
         <p:spPr>
           <a:xfrm>
-            <a:off x="1417320" y="4709160"/>
-            <a:ext cx="19050" cy="365760"/>
+            <a:off x="1417320" y="4654296"/>
+            <a:ext cx="19050" cy="429768"/>
           </a:xfrm>
           <a:prstGeom prst="rect">
             <a:avLst/>
@@ -7034,8 +7034,8 @@
         </p:nvSpPr>
         <p:spPr>
           <a:xfrm>
-            <a:off x="1691640" y="4617720"/>
-            <a:ext cx="3200400" cy="548640"/>
+            <a:off x="1691640" y="4562856"/>
+            <a:ext cx="3200400" cy="612648"/>
           </a:xfrm>
           <a:prstGeom prst="rect">
             <a:avLst/>
@@ -7073,8 +7073,8 @@
         </p:nvSpPr>
         <p:spPr>
           <a:xfrm>
-            <a:off x="5074920" y="4617720"/>
-            <a:ext cx="3931920" cy="548640"/>
+            <a:off x="5074920" y="4562856"/>
+            <a:ext cx="3931920" cy="612648"/>
           </a:xfrm>
           <a:prstGeom prst="rect">
             <a:avLst/>
@@ -7089,11 +7089,11 @@
           <a:p>
             <a:pPr algn="l">
               <a:lnSpc>
-                <a:spcPct val="132000"/>
+                <a:spcPct val="128000"/>
               </a:lnSpc>
             </a:pPr>
             <a:r>
-              <a:rPr sz="1100" b="0" i="0">
+              <a:rPr sz="1000" b="0" i="0">
                 <a:solidFill>
                   <a:srgbClr val="141413"/>
                 </a:solidFill>
@@ -7112,8 +7112,8 @@
         </p:nvSpPr>
         <p:spPr>
           <a:xfrm>
-            <a:off x="9189720" y="4617720"/>
-            <a:ext cx="2286000" cy="548640"/>
+            <a:off x="9189720" y="4562856"/>
+            <a:ext cx="2286000" cy="612648"/>
           </a:xfrm>
           <a:prstGeom prst="rect">
             <a:avLst/>
@@ -7128,11 +7128,11 @@
           <a:p>
             <a:pPr algn="l">
               <a:lnSpc>
-                <a:spcPct val="130000"/>
+                <a:spcPct val="128000"/>
               </a:lnSpc>
             </a:pPr>
             <a:r>
-              <a:rPr sz="1000" b="0" i="1">
+              <a:rPr sz="900" b="0" i="1">
                 <a:solidFill>
                   <a:srgbClr val="788C5D"/>
                 </a:solidFill>
@@ -7151,7 +7151,7 @@
         </p:nvSpPr>
         <p:spPr>
           <a:xfrm>
-            <a:off x="640080" y="5158740"/>
+            <a:off x="640080" y="5167884"/>
             <a:ext cx="10911535" cy="6350"/>
           </a:xfrm>
           <a:prstGeom prst="rect">
@@ -7196,8 +7196,8 @@
         </p:nvSpPr>
         <p:spPr>
           <a:xfrm>
-            <a:off x="640080" y="5166360"/>
-            <a:ext cx="777240" cy="548640"/>
+            <a:off x="640080" y="5175504"/>
+            <a:ext cx="777240" cy="612648"/>
           </a:xfrm>
           <a:prstGeom prst="rect">
             <a:avLst/>
@@ -7231,8 +7231,8 @@
         </p:nvSpPr>
         <p:spPr>
           <a:xfrm>
-            <a:off x="1417320" y="5257800"/>
-            <a:ext cx="19050" cy="365760"/>
+            <a:off x="1417320" y="5266944"/>
+            <a:ext cx="19050" cy="429768"/>
           </a:xfrm>
           <a:prstGeom prst="rect">
             <a:avLst/>
@@ -7276,8 +7276,8 @@
         </p:nvSpPr>
         <p:spPr>
           <a:xfrm>
-            <a:off x="1691640" y="5166360"/>
-            <a:ext cx="3200400" cy="548640"/>
+            <a:off x="1691640" y="5175504"/>
+            <a:ext cx="3200400" cy="612648"/>
           </a:xfrm>
           <a:prstGeom prst="rect">
             <a:avLst/>
@@ -7315,8 +7315,8 @@
         </p:nvSpPr>
         <p:spPr>
           <a:xfrm>
-            <a:off x="5074920" y="5166360"/>
-            <a:ext cx="3931920" cy="548640"/>
+            <a:off x="5074920" y="5175504"/>
+            <a:ext cx="3931920" cy="612648"/>
           </a:xfrm>
           <a:prstGeom prst="rect">
             <a:avLst/>
@@ -7331,11 +7331,11 @@
           <a:p>
             <a:pPr algn="l">
               <a:lnSpc>
-                <a:spcPct val="132000"/>
+                <a:spcPct val="128000"/>
               </a:lnSpc>
             </a:pPr>
             <a:r>
-              <a:rPr sz="1100" b="0" i="0">
+              <a:rPr sz="1000" b="0" i="0">
                 <a:solidFill>
                   <a:srgbClr val="141413"/>
                 </a:solidFill>
@@ -7354,8 +7354,8 @@
         </p:nvSpPr>
         <p:spPr>
           <a:xfrm>
-            <a:off x="9189720" y="5166360"/>
-            <a:ext cx="2286000" cy="548640"/>
+            <a:off x="9189720" y="5175504"/>
+            <a:ext cx="2286000" cy="612648"/>
           </a:xfrm>
           <a:prstGeom prst="rect">
             <a:avLst/>
@@ -7370,11 +7370,11 @@
           <a:p>
             <a:pPr algn="l">
               <a:lnSpc>
-                <a:spcPct val="130000"/>
+                <a:spcPct val="128000"/>
               </a:lnSpc>
             </a:pPr>
             <a:r>
-              <a:rPr sz="1000" b="0" i="1">
+              <a:rPr sz="900" b="0" i="1">
                 <a:solidFill>
                   <a:srgbClr val="D97757"/>
                 </a:solidFill>
@@ -7393,7 +7393,7 @@
         </p:nvSpPr>
         <p:spPr>
           <a:xfrm>
-            <a:off x="640080" y="5707380"/>
+            <a:off x="640080" y="5780532"/>
             <a:ext cx="10911535" cy="6350"/>
           </a:xfrm>
           <a:prstGeom prst="rect">
@@ -7438,8 +7438,8 @@
         </p:nvSpPr>
         <p:spPr>
           <a:xfrm>
-            <a:off x="640080" y="5715000"/>
-            <a:ext cx="777240" cy="548640"/>
+            <a:off x="640080" y="5788152"/>
+            <a:ext cx="777240" cy="612648"/>
           </a:xfrm>
           <a:prstGeom prst="rect">
             <a:avLst/>
@@ -7473,8 +7473,8 @@
         </p:nvSpPr>
         <p:spPr>
           <a:xfrm>
-            <a:off x="1417320" y="5806440"/>
-            <a:ext cx="19050" cy="365760"/>
+            <a:off x="1417320" y="5879592"/>
+            <a:ext cx="19050" cy="429768"/>
           </a:xfrm>
           <a:prstGeom prst="rect">
             <a:avLst/>
@@ -7518,8 +7518,8 @@
         </p:nvSpPr>
         <p:spPr>
           <a:xfrm>
-            <a:off x="1691640" y="5715000"/>
-            <a:ext cx="3200400" cy="548640"/>
+            <a:off x="1691640" y="5788152"/>
+            <a:ext cx="3200400" cy="612648"/>
           </a:xfrm>
           <a:prstGeom prst="rect">
             <a:avLst/>
@@ -7557,8 +7557,8 @@
         </p:nvSpPr>
         <p:spPr>
           <a:xfrm>
-            <a:off x="5074920" y="5715000"/>
-            <a:ext cx="3931920" cy="548640"/>
+            <a:off x="5074920" y="5788152"/>
+            <a:ext cx="3931920" cy="612648"/>
           </a:xfrm>
           <a:prstGeom prst="rect">
             <a:avLst/>
@@ -7573,11 +7573,11 @@
           <a:p>
             <a:pPr algn="l">
               <a:lnSpc>
-                <a:spcPct val="132000"/>
+                <a:spcPct val="128000"/>
               </a:lnSpc>
             </a:pPr>
             <a:r>
-              <a:rPr sz="1100" b="0" i="0">
+              <a:rPr sz="1000" b="0" i="0">
                 <a:solidFill>
                   <a:srgbClr val="141413"/>
                 </a:solidFill>
@@ -7596,8 +7596,8 @@
         </p:nvSpPr>
         <p:spPr>
           <a:xfrm>
-            <a:off x="9189720" y="5715000"/>
-            <a:ext cx="2286000" cy="548640"/>
+            <a:off x="9189720" y="5788152"/>
+            <a:ext cx="2286000" cy="612648"/>
           </a:xfrm>
           <a:prstGeom prst="rect">
             <a:avLst/>
@@ -7612,11 +7612,11 @@
           <a:p>
             <a:pPr algn="l">
               <a:lnSpc>
-                <a:spcPct val="130000"/>
+                <a:spcPct val="128000"/>
               </a:lnSpc>
             </a:pPr>
             <a:r>
-              <a:rPr sz="1000" b="0" i="1">
+              <a:rPr sz="900" b="0" i="1">
                 <a:solidFill>
                   <a:srgbClr val="6A9BCC"/>
                 </a:solidFill>
@@ -7635,7 +7635,7 @@
         </p:nvSpPr>
         <p:spPr>
           <a:xfrm>
-            <a:off x="640080" y="6256020"/>
+            <a:off x="640080" y="6393180"/>
             <a:ext cx="10911535" cy="6350"/>
           </a:xfrm>
           <a:prstGeom prst="rect">

</xml_diff>